<commit_message>
Update 23pp file with the barriers slide content
The prior rename committed the pre-barriers binary; this commits the actual
23-page deck (adds 'Why this opportunity isn't arbitraged away').

https://claude.ai/code/session_01HRMxSvt6t94q3GFGUqavQe
</commit_message>
<xml_diff>
--- a/Athanase_Endowment_Pitch_23pp.pptx
+++ b/Athanase_Endowment_Pitch_23pp.pptx
@@ -15,6 +15,7 @@
     <p:sldId id="284" r:id="rId9"/>
     <p:sldId id="271" r:id="rId10"/>
     <p:sldId id="341" r:id="rId11"/>
+    <p:sldId id="342" r:id="rId34"/>
     <p:sldId id="278" r:id="rId12"/>
     <p:sldId id="339" r:id="rId13"/>
     <p:sldId id="279" r:id="rId14"/>
@@ -5183,7 +5184,7 @@
                 </a:solidFill>
                 <a:latin typeface="Arial"/>
               </a:rPr>
-              <a:t>Strictly confidential          10</a:t>
+              <a:t>Strictly confidential          11</a:t>
             </a:r>
           </a:p>
         </p:txBody>
@@ -6215,7 +6216,7 @@
                 </a:solidFill>
                 <a:latin typeface="Arial"/>
               </a:rPr>
-              <a:t>Strictly confidential          11</a:t>
+              <a:t>Strictly confidential          12</a:t>
             </a:r>
           </a:p>
         </p:txBody>
@@ -8679,7 +8680,7 @@
                 </a:solidFill>
                 <a:latin typeface="Arial"/>
               </a:rPr>
-              <a:t>Strictly confidential          12</a:t>
+              <a:t>Strictly confidential          13</a:t>
             </a:r>
           </a:p>
         </p:txBody>
@@ -9633,7 +9634,7 @@
                 </a:solidFill>
                 <a:latin typeface="Arial"/>
               </a:rPr>
-              <a:t>Strictly confidential          13</a:t>
+              <a:t>Strictly confidential          14</a:t>
             </a:r>
           </a:p>
         </p:txBody>
@@ -11116,7 +11117,7 @@
                 </a:solidFill>
                 <a:latin typeface="Arial"/>
               </a:rPr>
-              <a:t>Strictly confidential          14</a:t>
+              <a:t>Strictly confidential          15</a:t>
             </a:r>
           </a:p>
         </p:txBody>
@@ -13065,7 +13066,7 @@
                 </a:solidFill>
                 <a:latin typeface="Arial"/>
               </a:rPr>
-              <a:t>Strictly confidential          15</a:t>
+              <a:t>Strictly confidential          16</a:t>
             </a:r>
           </a:p>
         </p:txBody>
@@ -14840,7 +14841,7 @@
                 </a:solidFill>
                 <a:latin typeface="Arial"/>
               </a:rPr>
-              <a:t>Strictly confidential          16</a:t>
+              <a:t>Strictly confidential          17</a:t>
             </a:r>
           </a:p>
         </p:txBody>
@@ -15855,7 +15856,7 @@
                 </a:solidFill>
                 <a:latin typeface="Arial"/>
               </a:rPr>
-              <a:t>Strictly confidential          17</a:t>
+              <a:t>Strictly confidential          18</a:t>
             </a:r>
           </a:p>
         </p:txBody>
@@ -19877,7 +19878,7 @@
                 </a:solidFill>
                 <a:latin typeface="Arial"/>
               </a:rPr>
-              <a:t>Strictly confidential          18</a:t>
+              <a:t>Strictly confidential          19</a:t>
             </a:r>
           </a:p>
         </p:txBody>
@@ -20731,7 +20732,7 @@
                 </a:solidFill>
                 <a:latin typeface="Arial"/>
               </a:rPr>
-              <a:t>Strictly confidential          19</a:t>
+              <a:t>Strictly confidential          20</a:t>
             </a:r>
           </a:p>
         </p:txBody>
@@ -23592,7 +23593,7 @@
                 </a:solidFill>
                 <a:latin typeface="Arial"/>
               </a:rPr>
-              <a:t>Strictly confidential          20</a:t>
+              <a:t>Strictly confidential          21</a:t>
             </a:r>
           </a:p>
         </p:txBody>
@@ -24490,7 +24491,7 @@
                 </a:solidFill>
                 <a:latin typeface="Arial"/>
               </a:rPr>
-              <a:t>Strictly confidential          21</a:t>
+              <a:t>Strictly confidential          22</a:t>
             </a:r>
           </a:p>
         </p:txBody>
@@ -24952,7 +24953,7 @@
                 </a:solidFill>
                 <a:latin typeface="Arial"/>
               </a:rPr>
-              <a:t>Strictly confidential          22</a:t>
+              <a:t>Strictly confidential          23</a:t>
             </a:r>
           </a:p>
         </p:txBody>
@@ -32225,7 +32226,7 @@
                 </a:solidFill>
                 <a:latin typeface="Arial"/>
               </a:rPr>
-              <a:t>Strictly confidential          8</a:t>
+              <a:t>Strictly confidential          9</a:t>
             </a:r>
           </a:p>
         </p:txBody>
@@ -33181,7 +33182,7 @@
                 </a:solidFill>
                 <a:latin typeface="Arial"/>
               </a:rPr>
-              <a:t>Strictly confidential          9</a:t>
+              <a:t>Strictly confidential          10</a:t>
             </a:r>
           </a:p>
         </p:txBody>
@@ -34337,6 +34338,1089 @@
               </a:solidFill>
               <a:latin typeface="Arial"/>
             </a:endParaRPr>
+          </a:p>
+        </p:txBody>
+      </p:sp>
+    </p:spTree>
+  </p:cSld>
+  <p:clrMapOvr>
+    <a:masterClrMapping/>
+  </p:clrMapOvr>
+</p:sld>
+</file>
+
+<file path=ppt/slides/slide902.xml><?xml version="1.0" encoding="utf-8"?>
+<p:sld xmlns:a="http://schemas.openxmlformats.org/drawingml/2006/main" xmlns:p="http://schemas.openxmlformats.org/presentationml/2006/main" xmlns:r="http://schemas.openxmlformats.org/officeDocument/2006/relationships">
+  <p:cSld>
+    <p:spTree>
+      <p:nvGrpSpPr>
+        <p:cNvPr id="1" name=""/>
+        <p:cNvGrpSpPr/>
+        <p:nvPr/>
+      </p:nvGrpSpPr>
+      <p:grpSpPr/>
+      <p:sp>
+        <p:nvSpPr>
+          <p:cNvPr id="2" name="Rectangle 1"/>
+          <p:cNvSpPr/>
+          <p:nvPr/>
+        </p:nvSpPr>
+        <p:spPr>
+          <a:xfrm>
+            <a:off x="0" y="0"/>
+            <a:ext cx="9753600" cy="7315200"/>
+          </a:xfrm>
+          <a:prstGeom prst="rect">
+            <a:avLst/>
+          </a:prstGeom>
+          <a:solidFill>
+            <a:srgbClr val="FFFFFF"/>
+          </a:solidFill>
+          <a:ln>
+            <a:noFill/>
+          </a:ln>
+          <a:effectLst/>
+        </p:spPr>
+        <p:style>
+          <a:lnRef idx="1">
+            <a:schemeClr val="accent1"/>
+          </a:lnRef>
+          <a:fillRef idx="3">
+            <a:schemeClr val="accent1"/>
+          </a:fillRef>
+          <a:effectRef idx="2">
+            <a:schemeClr val="accent1"/>
+          </a:effectRef>
+          <a:fontRef idx="minor">
+            <a:schemeClr val="lt1"/>
+          </a:fontRef>
+        </p:style>
+        <p:txBody>
+          <a:bodyPr rtlCol="0" anchor="ctr"/>
+          <a:lstStyle/>
+          <a:p>
+            <a:pPr algn="ctr"/>
+            <a:endParaRPr/>
+          </a:p>
+        </p:txBody>
+      </p:sp>
+      <p:pic>
+        <p:nvPicPr>
+          <p:cNvPr id="3" name="Picture 2" descr="mark_dark.png"/>
+          <p:cNvPicPr>
+            <a:picLocks noChangeAspect="1"/>
+          </p:cNvPicPr>
+          <p:nvPr/>
+        </p:nvPicPr>
+        <p:blipFill>
+          <a:blip r:embed="rId2"/>
+          <a:stretch>
+            <a:fillRect/>
+          </a:stretch>
+        </p:blipFill>
+        <p:spPr>
+          <a:xfrm>
+            <a:off x="402346" y="234086"/>
+            <a:ext cx="224012" cy="190199"/>
+          </a:xfrm>
+          <a:prstGeom prst="rect">
+            <a:avLst/>
+          </a:prstGeom>
+        </p:spPr>
+      </p:pic>
+      <p:sp>
+        <p:nvSpPr>
+          <p:cNvPr id="4" name="TextBox 3"/>
+          <p:cNvSpPr txBox="1"/>
+          <p:nvPr/>
+        </p:nvSpPr>
+        <p:spPr>
+          <a:xfrm>
+            <a:off x="716907" y="263347"/>
+            <a:ext cx="5120768" cy="292608"/>
+          </a:xfrm>
+          <a:prstGeom prst="rect">
+            <a:avLst/>
+          </a:prstGeom>
+          <a:noFill/>
+        </p:spPr>
+        <p:txBody>
+          <a:bodyPr wrap="square" lIns="0" tIns="0" rIns="0" bIns="0" anchor="t">
+            <a:spAutoFit/>
+          </a:bodyPr>
+          <a:lstStyle/>
+          <a:p>
+            <a:pPr algn="l">
+              <a:lnSpc>
+                <a:spcPct val="110000"/>
+              </a:lnSpc>
+              <a:spcAft>
+                <a:spcPts val="0"/>
+              </a:spcAft>
+            </a:pPr>
+            <a:r>
+              <a:rPr sz="880" b="0" i="0">
+                <a:solidFill>
+                  <a:srgbClr val="556A83"/>
+                </a:solidFill>
+                <a:latin typeface="Arial"/>
+              </a:rPr>
+              <a:t>Barriers to Entry</a:t>
+            </a:r>
+          </a:p>
+        </p:txBody>
+      </p:sp>
+      <p:sp>
+        <p:nvSpPr>
+          <p:cNvPr id="5" name="Rectangle 4"/>
+          <p:cNvSpPr/>
+          <p:nvPr/>
+        </p:nvSpPr>
+        <p:spPr>
+          <a:xfrm>
+            <a:off x="0" y="604723"/>
+            <a:ext cx="9753600" cy="1414272"/>
+          </a:xfrm>
+          <a:prstGeom prst="rect">
+            <a:avLst/>
+          </a:prstGeom>
+          <a:solidFill>
+            <a:srgbClr val="F6F7F9"/>
+          </a:solidFill>
+          <a:ln>
+            <a:noFill/>
+          </a:ln>
+          <a:effectLst/>
+        </p:spPr>
+        <p:style>
+          <a:lnRef idx="1">
+            <a:schemeClr val="accent1"/>
+          </a:lnRef>
+          <a:fillRef idx="3">
+            <a:schemeClr val="accent1"/>
+          </a:fillRef>
+          <a:effectRef idx="2">
+            <a:schemeClr val="accent1"/>
+          </a:effectRef>
+          <a:fontRef idx="minor">
+            <a:schemeClr val="lt1"/>
+          </a:fontRef>
+        </p:style>
+        <p:txBody>
+          <a:bodyPr rtlCol="0" anchor="ctr"/>
+          <a:lstStyle/>
+          <a:p>
+            <a:pPr algn="ctr"/>
+            <a:endParaRPr/>
+          </a:p>
+        </p:txBody>
+      </p:sp>
+      <p:sp>
+        <p:nvSpPr>
+          <p:cNvPr id="6" name="TextBox 5"/>
+          <p:cNvSpPr txBox="1"/>
+          <p:nvPr/>
+        </p:nvSpPr>
+        <p:spPr>
+          <a:xfrm>
+            <a:off x="438922" y="721766"/>
+            <a:ext cx="8851613" cy="829056"/>
+          </a:xfrm>
+          <a:prstGeom prst="rect">
+            <a:avLst/>
+          </a:prstGeom>
+          <a:noFill/>
+        </p:spPr>
+        <p:txBody>
+          <a:bodyPr wrap="square" lIns="0" tIns="0" rIns="0" bIns="0" anchor="t">
+            <a:spAutoFit/>
+          </a:bodyPr>
+          <a:lstStyle/>
+          <a:p>
+            <a:pPr algn="l">
+              <a:lnSpc>
+                <a:spcPct val="110000"/>
+              </a:lnSpc>
+              <a:spcAft>
+                <a:spcPts val="200"/>
+              </a:spcAft>
+            </a:pPr>
+            <a:r>
+              <a:rPr sz="2400" b="0" i="0" spc="-90">
+                <a:solidFill>
+                  <a:srgbClr val="314359"/>
+                </a:solidFill>
+                <a:latin typeface="Times New Roman"/>
+              </a:rPr>
+              <a:t>Why this opportunity isn’t arbitraged away</a:t>
+            </a:r>
+          </a:p>
+        </p:txBody>
+      </p:sp>
+      <p:sp>
+        <p:nvSpPr>
+          <p:cNvPr id="7" name="TextBox 6"/>
+          <p:cNvSpPr txBox="1"/>
+          <p:nvPr/>
+        </p:nvSpPr>
+        <p:spPr>
+          <a:xfrm>
+            <a:off x="453553" y="1511808"/>
+            <a:ext cx="8705305" cy="487680"/>
+          </a:xfrm>
+          <a:prstGeom prst="rect">
+            <a:avLst/>
+          </a:prstGeom>
+          <a:noFill/>
+        </p:spPr>
+        <p:txBody>
+          <a:bodyPr wrap="square" lIns="0" tIns="0" rIns="0" bIns="0" anchor="t">
+            <a:spAutoFit/>
+          </a:bodyPr>
+          <a:lstStyle/>
+          <a:p>
+            <a:pPr algn="l">
+              <a:lnSpc>
+                <a:spcPct val="110000"/>
+              </a:lnSpc>
+              <a:spcAft>
+                <a:spcPts val="0"/>
+              </a:spcAft>
+            </a:pPr>
+            <a:r>
+              <a:rPr sz="1040" b="0" i="1">
+                <a:solidFill>
+                  <a:srgbClr val="556A83"/>
+                </a:solidFill>
+                <a:latin typeface="Arial"/>
+              </a:rPr>
+              <a:t>Engaged ownership is hard, uncomfortable and off-mandate for most investors — so the crowd stays away and the inefficiency is never competed out. Four barriers keep the lane open.</a:t>
+            </a:r>
+          </a:p>
+        </p:txBody>
+      </p:sp>
+      <p:sp>
+        <p:nvSpPr>
+          <p:cNvPr id="8" name="TextBox 7"/>
+          <p:cNvSpPr txBox="1"/>
+          <p:nvPr/>
+        </p:nvSpPr>
+        <p:spPr>
+          <a:xfrm>
+            <a:off x="6583844" y="6876288"/>
+            <a:ext cx="2926153" cy="292608"/>
+          </a:xfrm>
+          <a:prstGeom prst="rect">
+            <a:avLst/>
+          </a:prstGeom>
+          <a:noFill/>
+        </p:spPr>
+        <p:txBody>
+          <a:bodyPr wrap="square" lIns="0" tIns="0" rIns="0" bIns="0" anchor="t">
+            <a:spAutoFit/>
+          </a:bodyPr>
+          <a:lstStyle/>
+          <a:p>
+            <a:pPr algn="r">
+              <a:lnSpc>
+                <a:spcPct val="110000"/>
+              </a:lnSpc>
+              <a:spcAft>
+                <a:spcPts val="0"/>
+              </a:spcAft>
+            </a:pPr>
+            <a:r>
+              <a:rPr sz="680" b="0" i="0">
+                <a:solidFill>
+                  <a:srgbClr val="556A83"/>
+                </a:solidFill>
+                <a:latin typeface="Arial"/>
+              </a:rPr>
+              <a:t>Strictly confidential          8</a:t>
+            </a:r>
+          </a:p>
+        </p:txBody>
+      </p:sp>
+      <p:sp>
+        <p:nvSpPr>
+          <p:cNvPr id="9" name="Rectangle 8"/>
+          <p:cNvSpPr/>
+          <p:nvPr/>
+        </p:nvSpPr>
+        <p:spPr>
+          <a:xfrm>
+            <a:off x="438922" y="2292096"/>
+            <a:ext cx="4330706" cy="1892198"/>
+          </a:xfrm>
+          <a:prstGeom prst="rect">
+            <a:avLst/>
+          </a:prstGeom>
+          <a:solidFill>
+            <a:srgbClr val="F6F7F9"/>
+          </a:solidFill>
+          <a:ln>
+            <a:noFill/>
+          </a:ln>
+          <a:effectLst/>
+        </p:spPr>
+        <p:style>
+          <a:lnRef idx="1">
+            <a:schemeClr val="accent1"/>
+          </a:lnRef>
+          <a:fillRef idx="3">
+            <a:schemeClr val="accent1"/>
+          </a:fillRef>
+          <a:effectRef idx="2">
+            <a:schemeClr val="accent1"/>
+          </a:effectRef>
+          <a:fontRef idx="minor">
+            <a:schemeClr val="lt1"/>
+          </a:fontRef>
+        </p:style>
+        <p:txBody>
+          <a:bodyPr rtlCol="0" anchor="ctr"/>
+          <a:lstStyle/>
+          <a:p>
+            <a:pPr algn="ctr"/>
+            <a:endParaRPr/>
+          </a:p>
+        </p:txBody>
+      </p:sp>
+      <p:sp>
+        <p:nvSpPr>
+          <p:cNvPr id="10" name="Rectangle 9"/>
+          <p:cNvSpPr/>
+          <p:nvPr/>
+        </p:nvSpPr>
+        <p:spPr>
+          <a:xfrm>
+            <a:off x="438922" y="2292096"/>
+            <a:ext cx="51207" cy="1892198"/>
+          </a:xfrm>
+          <a:prstGeom prst="rect">
+            <a:avLst/>
+          </a:prstGeom>
+          <a:solidFill>
+            <a:srgbClr val="152130"/>
+          </a:solidFill>
+          <a:ln>
+            <a:noFill/>
+          </a:ln>
+          <a:effectLst/>
+        </p:spPr>
+        <p:style>
+          <a:lnRef idx="1">
+            <a:schemeClr val="accent1"/>
+          </a:lnRef>
+          <a:fillRef idx="3">
+            <a:schemeClr val="accent1"/>
+          </a:fillRef>
+          <a:effectRef idx="2">
+            <a:schemeClr val="accent1"/>
+          </a:effectRef>
+          <a:fontRef idx="minor">
+            <a:schemeClr val="lt1"/>
+          </a:fontRef>
+        </p:style>
+        <p:txBody>
+          <a:bodyPr rtlCol="0" anchor="ctr"/>
+          <a:lstStyle/>
+          <a:p>
+            <a:pPr algn="ctr"/>
+            <a:endParaRPr/>
+          </a:p>
+        </p:txBody>
+      </p:sp>
+      <p:sp>
+        <p:nvSpPr>
+          <p:cNvPr id="11" name="TextBox 10"/>
+          <p:cNvSpPr txBox="1"/>
+          <p:nvPr/>
+        </p:nvSpPr>
+        <p:spPr>
+          <a:xfrm>
+            <a:off x="629122" y="2418892"/>
+            <a:ext cx="4023460" cy="390144"/>
+          </a:xfrm>
+          <a:prstGeom prst="rect">
+            <a:avLst/>
+          </a:prstGeom>
+          <a:noFill/>
+        </p:spPr>
+        <p:txBody>
+          <a:bodyPr wrap="square" lIns="0" tIns="0" rIns="0" bIns="0" anchor="t">
+            <a:spAutoFit/>
+          </a:bodyPr>
+          <a:lstStyle/>
+          <a:p>
+            <a:pPr algn="l">
+              <a:lnSpc>
+                <a:spcPct val="110000"/>
+              </a:lnSpc>
+              <a:spcAft>
+                <a:spcPts val="0"/>
+              </a:spcAft>
+            </a:pPr>
+            <a:r>
+              <a:rPr sz="1080" b="1" i="0">
+                <a:solidFill>
+                  <a:srgbClr val="152130"/>
+                </a:solidFill>
+                <a:latin typeface="Times New Roman"/>
+              </a:rPr>
+              <a:t>Fear keeps the crowd on the sidelines</a:t>
+            </a:r>
+          </a:p>
+        </p:txBody>
+      </p:sp>
+      <p:sp>
+        <p:nvSpPr>
+          <p:cNvPr id="12" name="TextBox 11"/>
+          <p:cNvSpPr txBox="1"/>
+          <p:nvPr/>
+        </p:nvSpPr>
+        <p:spPr>
+          <a:xfrm>
+            <a:off x="629122" y="2828544"/>
+            <a:ext cx="3994199" cy="1267968"/>
+          </a:xfrm>
+          <a:prstGeom prst="rect">
+            <a:avLst/>
+          </a:prstGeom>
+          <a:noFill/>
+        </p:spPr>
+        <p:txBody>
+          <a:bodyPr wrap="square" lIns="0" tIns="0" rIns="0" bIns="0" anchor="t">
+            <a:spAutoFit/>
+          </a:bodyPr>
+          <a:lstStyle/>
+          <a:p>
+            <a:pPr algn="l">
+              <a:lnSpc>
+                <a:spcPct val="113000"/>
+              </a:lnSpc>
+              <a:spcAft>
+                <a:spcPts val="0"/>
+              </a:spcAft>
+            </a:pPr>
+            <a:r>
+              <a:rPr sz="880" b="0" i="0">
+                <a:solidFill>
+                  <a:srgbClr val="0E1620"/>
+                </a:solidFill>
+                <a:latin typeface="Arial"/>
+              </a:rPr>
+              <a:t>Most investors avoid a company while it is underperforming and wait for the turn — buying back only once results visibly improve, and the price with them. We do the opposite: we buy at the point of maximum doubt and create the improvement ourselves.</a:t>
+            </a:r>
+          </a:p>
+        </p:txBody>
+      </p:sp>
+      <p:sp>
+        <p:nvSpPr>
+          <p:cNvPr id="13" name="Rectangle 12"/>
+          <p:cNvSpPr/>
+          <p:nvPr/>
+        </p:nvSpPr>
+        <p:spPr>
+          <a:xfrm>
+            <a:off x="4981775" y="2292096"/>
+            <a:ext cx="4330706" cy="1892198"/>
+          </a:xfrm>
+          <a:prstGeom prst="rect">
+            <a:avLst/>
+          </a:prstGeom>
+          <a:solidFill>
+            <a:srgbClr val="F6F7F9"/>
+          </a:solidFill>
+          <a:ln>
+            <a:noFill/>
+          </a:ln>
+          <a:effectLst/>
+        </p:spPr>
+        <p:style>
+          <a:lnRef idx="1">
+            <a:schemeClr val="accent1"/>
+          </a:lnRef>
+          <a:fillRef idx="3">
+            <a:schemeClr val="accent1"/>
+          </a:fillRef>
+          <a:effectRef idx="2">
+            <a:schemeClr val="accent1"/>
+          </a:effectRef>
+          <a:fontRef idx="minor">
+            <a:schemeClr val="lt1"/>
+          </a:fontRef>
+        </p:style>
+        <p:txBody>
+          <a:bodyPr rtlCol="0" anchor="ctr"/>
+          <a:lstStyle/>
+          <a:p>
+            <a:pPr algn="ctr"/>
+            <a:endParaRPr/>
+          </a:p>
+        </p:txBody>
+      </p:sp>
+      <p:sp>
+        <p:nvSpPr>
+          <p:cNvPr id="14" name="Rectangle 13"/>
+          <p:cNvSpPr/>
+          <p:nvPr/>
+        </p:nvSpPr>
+        <p:spPr>
+          <a:xfrm>
+            <a:off x="4981775" y="2292096"/>
+            <a:ext cx="51207" cy="1892198"/>
+          </a:xfrm>
+          <a:prstGeom prst="rect">
+            <a:avLst/>
+          </a:prstGeom>
+          <a:solidFill>
+            <a:srgbClr val="152130"/>
+          </a:solidFill>
+          <a:ln>
+            <a:noFill/>
+          </a:ln>
+          <a:effectLst/>
+        </p:spPr>
+        <p:style>
+          <a:lnRef idx="1">
+            <a:schemeClr val="accent1"/>
+          </a:lnRef>
+          <a:fillRef idx="3">
+            <a:schemeClr val="accent1"/>
+          </a:fillRef>
+          <a:effectRef idx="2">
+            <a:schemeClr val="accent1"/>
+          </a:effectRef>
+          <a:fontRef idx="minor">
+            <a:schemeClr val="lt1"/>
+          </a:fontRef>
+        </p:style>
+        <p:txBody>
+          <a:bodyPr rtlCol="0" anchor="ctr"/>
+          <a:lstStyle/>
+          <a:p>
+            <a:pPr algn="ctr"/>
+            <a:endParaRPr/>
+          </a:p>
+        </p:txBody>
+      </p:sp>
+      <p:sp>
+        <p:nvSpPr>
+          <p:cNvPr id="15" name="TextBox 14"/>
+          <p:cNvSpPr txBox="1"/>
+          <p:nvPr/>
+        </p:nvSpPr>
+        <p:spPr>
+          <a:xfrm>
+            <a:off x="5171975" y="2418892"/>
+            <a:ext cx="4023460" cy="390144"/>
+          </a:xfrm>
+          <a:prstGeom prst="rect">
+            <a:avLst/>
+          </a:prstGeom>
+          <a:noFill/>
+        </p:spPr>
+        <p:txBody>
+          <a:bodyPr wrap="square" lIns="0" tIns="0" rIns="0" bIns="0" anchor="t">
+            <a:spAutoFit/>
+          </a:bodyPr>
+          <a:lstStyle/>
+          <a:p>
+            <a:pPr algn="l">
+              <a:lnSpc>
+                <a:spcPct val="110000"/>
+              </a:lnSpc>
+              <a:spcAft>
+                <a:spcPts val="0"/>
+              </a:spcAft>
+            </a:pPr>
+            <a:r>
+              <a:rPr sz="1080" b="1" i="0">
+                <a:solidFill>
+                  <a:srgbClr val="152130"/>
+                </a:solidFill>
+                <a:latin typeface="Times New Roman"/>
+              </a:rPr>
+              <a:t>The skill bar is genuinely high</a:t>
+            </a:r>
+          </a:p>
+        </p:txBody>
+      </p:sp>
+      <p:sp>
+        <p:nvSpPr>
+          <p:cNvPr id="16" name="TextBox 15"/>
+          <p:cNvSpPr txBox="1"/>
+          <p:nvPr/>
+        </p:nvSpPr>
+        <p:spPr>
+          <a:xfrm>
+            <a:off x="5171975" y="2828544"/>
+            <a:ext cx="3994199" cy="1267968"/>
+          </a:xfrm>
+          <a:prstGeom prst="rect">
+            <a:avLst/>
+          </a:prstGeom>
+          <a:noFill/>
+        </p:spPr>
+        <p:txBody>
+          <a:bodyPr wrap="square" lIns="0" tIns="0" rIns="0" bIns="0" anchor="t">
+            <a:spAutoFit/>
+          </a:bodyPr>
+          <a:lstStyle/>
+          <a:p>
+            <a:pPr algn="l">
+              <a:lnSpc>
+                <a:spcPct val="113000"/>
+              </a:lnSpc>
+              <a:spcAft>
+                <a:spcPts val="0"/>
+              </a:spcAft>
+            </a:pPr>
+            <a:r>
+              <a:rPr sz="880" b="0" i="0">
+                <a:solidFill>
+                  <a:srgbClr val="0E1620"/>
+                </a:solidFill>
+                <a:latin typeface="Arial"/>
+              </a:rPr>
+              <a:t>It takes three things at once — operating credibility, deep investment experience, and the psychological strength to convince a board and fellow shareholders you are right. Few managers have all three, so few can even attempt it.</a:t>
+            </a:r>
+          </a:p>
+        </p:txBody>
+      </p:sp>
+      <p:sp>
+        <p:nvSpPr>
+          <p:cNvPr id="17" name="Rectangle 16"/>
+          <p:cNvSpPr/>
+          <p:nvPr/>
+        </p:nvSpPr>
+        <p:spPr>
+          <a:xfrm>
+            <a:off x="438922" y="4340352"/>
+            <a:ext cx="4330706" cy="1892198"/>
+          </a:xfrm>
+          <a:prstGeom prst="rect">
+            <a:avLst/>
+          </a:prstGeom>
+          <a:solidFill>
+            <a:srgbClr val="F6F7F9"/>
+          </a:solidFill>
+          <a:ln>
+            <a:noFill/>
+          </a:ln>
+          <a:effectLst/>
+        </p:spPr>
+        <p:style>
+          <a:lnRef idx="1">
+            <a:schemeClr val="accent1"/>
+          </a:lnRef>
+          <a:fillRef idx="3">
+            <a:schemeClr val="accent1"/>
+          </a:fillRef>
+          <a:effectRef idx="2">
+            <a:schemeClr val="accent1"/>
+          </a:effectRef>
+          <a:fontRef idx="minor">
+            <a:schemeClr val="lt1"/>
+          </a:fontRef>
+        </p:style>
+        <p:txBody>
+          <a:bodyPr rtlCol="0" anchor="ctr"/>
+          <a:lstStyle/>
+          <a:p>
+            <a:pPr algn="ctr"/>
+            <a:endParaRPr/>
+          </a:p>
+        </p:txBody>
+      </p:sp>
+      <p:sp>
+        <p:nvSpPr>
+          <p:cNvPr id="18" name="Rectangle 17"/>
+          <p:cNvSpPr/>
+          <p:nvPr/>
+        </p:nvSpPr>
+        <p:spPr>
+          <a:xfrm>
+            <a:off x="438922" y="4340352"/>
+            <a:ext cx="51207" cy="1892198"/>
+          </a:xfrm>
+          <a:prstGeom prst="rect">
+            <a:avLst/>
+          </a:prstGeom>
+          <a:solidFill>
+            <a:srgbClr val="152130"/>
+          </a:solidFill>
+          <a:ln>
+            <a:noFill/>
+          </a:ln>
+          <a:effectLst/>
+        </p:spPr>
+        <p:style>
+          <a:lnRef idx="1">
+            <a:schemeClr val="accent1"/>
+          </a:lnRef>
+          <a:fillRef idx="3">
+            <a:schemeClr val="accent1"/>
+          </a:fillRef>
+          <a:effectRef idx="2">
+            <a:schemeClr val="accent1"/>
+          </a:effectRef>
+          <a:fontRef idx="minor">
+            <a:schemeClr val="lt1"/>
+          </a:fontRef>
+        </p:style>
+        <p:txBody>
+          <a:bodyPr rtlCol="0" anchor="ctr"/>
+          <a:lstStyle/>
+          <a:p>
+            <a:pPr algn="ctr"/>
+            <a:endParaRPr/>
+          </a:p>
+        </p:txBody>
+      </p:sp>
+      <p:sp>
+        <p:nvSpPr>
+          <p:cNvPr id="19" name="TextBox 18"/>
+          <p:cNvSpPr txBox="1"/>
+          <p:nvPr/>
+        </p:nvSpPr>
+        <p:spPr>
+          <a:xfrm>
+            <a:off x="629122" y="4467148"/>
+            <a:ext cx="4023460" cy="390144"/>
+          </a:xfrm>
+          <a:prstGeom prst="rect">
+            <a:avLst/>
+          </a:prstGeom>
+          <a:noFill/>
+        </p:spPr>
+        <p:txBody>
+          <a:bodyPr wrap="square" lIns="0" tIns="0" rIns="0" bIns="0" anchor="t">
+            <a:spAutoFit/>
+          </a:bodyPr>
+          <a:lstStyle/>
+          <a:p>
+            <a:pPr algn="l">
+              <a:lnSpc>
+                <a:spcPct val="110000"/>
+              </a:lnSpc>
+              <a:spcAft>
+                <a:spcPts val="0"/>
+              </a:spcAft>
+            </a:pPr>
+            <a:r>
+              <a:rPr sz="1080" b="1" i="0">
+                <a:solidFill>
+                  <a:srgbClr val="152130"/>
+                </a:solidFill>
+                <a:latin typeface="Times New Roman"/>
+              </a:rPr>
+              <a:t>Career risk — and the wrong mandate</a:t>
+            </a:r>
+          </a:p>
+        </p:txBody>
+      </p:sp>
+      <p:sp>
+        <p:nvSpPr>
+          <p:cNvPr id="20" name="TextBox 19"/>
+          <p:cNvSpPr txBox="1"/>
+          <p:nvPr/>
+        </p:nvSpPr>
+        <p:spPr>
+          <a:xfrm>
+            <a:off x="629122" y="4876800"/>
+            <a:ext cx="3994199" cy="1267968"/>
+          </a:xfrm>
+          <a:prstGeom prst="rect">
+            <a:avLst/>
+          </a:prstGeom>
+          <a:noFill/>
+        </p:spPr>
+        <p:txBody>
+          <a:bodyPr wrap="square" lIns="0" tIns="0" rIns="0" bIns="0" anchor="t">
+            <a:spAutoFit/>
+          </a:bodyPr>
+          <a:lstStyle/>
+          <a:p>
+            <a:pPr algn="l">
+              <a:lnSpc>
+                <a:spcPct val="113000"/>
+              </a:lnSpc>
+              <a:spcAft>
+                <a:spcPts val="0"/>
+              </a:spcAft>
+            </a:pPr>
+            <a:r>
+              <a:rPr sz="880" b="0" i="0">
+                <a:solidFill>
+                  <a:srgbClr val="0E1620"/>
+                </a:solidFill>
+                <a:latin typeface="Arial"/>
+              </a:rPr>
+              <a:t>Voicing a public or private view on what a company must do carries real career risk; the typical, risk-averse equity manager would rather stay quiet. And most funds have no mandate to engage at all — they simply vote with their feet and sell.</a:t>
+            </a:r>
+          </a:p>
+        </p:txBody>
+      </p:sp>
+      <p:sp>
+        <p:nvSpPr>
+          <p:cNvPr id="21" name="Rectangle 20"/>
+          <p:cNvSpPr/>
+          <p:nvPr/>
+        </p:nvSpPr>
+        <p:spPr>
+          <a:xfrm>
+            <a:off x="4981775" y="4340352"/>
+            <a:ext cx="4330706" cy="1892198"/>
+          </a:xfrm>
+          <a:prstGeom prst="rect">
+            <a:avLst/>
+          </a:prstGeom>
+          <a:solidFill>
+            <a:srgbClr val="F6F7F9"/>
+          </a:solidFill>
+          <a:ln>
+            <a:noFill/>
+          </a:ln>
+          <a:effectLst/>
+        </p:spPr>
+        <p:style>
+          <a:lnRef idx="1">
+            <a:schemeClr val="accent1"/>
+          </a:lnRef>
+          <a:fillRef idx="3">
+            <a:schemeClr val="accent1"/>
+          </a:fillRef>
+          <a:effectRef idx="2">
+            <a:schemeClr val="accent1"/>
+          </a:effectRef>
+          <a:fontRef idx="minor">
+            <a:schemeClr val="lt1"/>
+          </a:fontRef>
+        </p:style>
+        <p:txBody>
+          <a:bodyPr rtlCol="0" anchor="ctr"/>
+          <a:lstStyle/>
+          <a:p>
+            <a:pPr algn="ctr"/>
+            <a:endParaRPr/>
+          </a:p>
+        </p:txBody>
+      </p:sp>
+      <p:sp>
+        <p:nvSpPr>
+          <p:cNvPr id="22" name="Rectangle 21"/>
+          <p:cNvSpPr/>
+          <p:nvPr/>
+        </p:nvSpPr>
+        <p:spPr>
+          <a:xfrm>
+            <a:off x="4981775" y="4340352"/>
+            <a:ext cx="51207" cy="1892198"/>
+          </a:xfrm>
+          <a:prstGeom prst="rect">
+            <a:avLst/>
+          </a:prstGeom>
+          <a:solidFill>
+            <a:srgbClr val="152130"/>
+          </a:solidFill>
+          <a:ln>
+            <a:noFill/>
+          </a:ln>
+          <a:effectLst/>
+        </p:spPr>
+        <p:style>
+          <a:lnRef idx="1">
+            <a:schemeClr val="accent1"/>
+          </a:lnRef>
+          <a:fillRef idx="3">
+            <a:schemeClr val="accent1"/>
+          </a:fillRef>
+          <a:effectRef idx="2">
+            <a:schemeClr val="accent1"/>
+          </a:effectRef>
+          <a:fontRef idx="minor">
+            <a:schemeClr val="lt1"/>
+          </a:fontRef>
+        </p:style>
+        <p:txBody>
+          <a:bodyPr rtlCol="0" anchor="ctr"/>
+          <a:lstStyle/>
+          <a:p>
+            <a:pPr algn="ctr"/>
+            <a:endParaRPr/>
+          </a:p>
+        </p:txBody>
+      </p:sp>
+      <p:sp>
+        <p:nvSpPr>
+          <p:cNvPr id="23" name="TextBox 22"/>
+          <p:cNvSpPr txBox="1"/>
+          <p:nvPr/>
+        </p:nvSpPr>
+        <p:spPr>
+          <a:xfrm>
+            <a:off x="5171975" y="4467148"/>
+            <a:ext cx="4023460" cy="390144"/>
+          </a:xfrm>
+          <a:prstGeom prst="rect">
+            <a:avLst/>
+          </a:prstGeom>
+          <a:noFill/>
+        </p:spPr>
+        <p:txBody>
+          <a:bodyPr wrap="square" lIns="0" tIns="0" rIns="0" bIns="0" anchor="t">
+            <a:spAutoFit/>
+          </a:bodyPr>
+          <a:lstStyle/>
+          <a:p>
+            <a:pPr algn="l">
+              <a:lnSpc>
+                <a:spcPct val="110000"/>
+              </a:lnSpc>
+              <a:spcAft>
+                <a:spcPts val="0"/>
+              </a:spcAft>
+            </a:pPr>
+            <a:r>
+              <a:rPr sz="1080" b="1" i="0">
+                <a:solidFill>
+                  <a:srgbClr val="152130"/>
+                </a:solidFill>
+                <a:latin typeface="Times New Roman"/>
+              </a:rPr>
+              <a:t>They misread the discount</a:t>
+            </a:r>
+          </a:p>
+        </p:txBody>
+      </p:sp>
+      <p:sp>
+        <p:nvSpPr>
+          <p:cNvPr id="24" name="TextBox 23"/>
+          <p:cNvSpPr txBox="1"/>
+          <p:nvPr/>
+        </p:nvSpPr>
+        <p:spPr>
+          <a:xfrm>
+            <a:off x="5171975" y="4876800"/>
+            <a:ext cx="3994199" cy="1267968"/>
+          </a:xfrm>
+          <a:prstGeom prst="rect">
+            <a:avLst/>
+          </a:prstGeom>
+          <a:noFill/>
+        </p:spPr>
+        <p:txBody>
+          <a:bodyPr wrap="square" lIns="0" tIns="0" rIns="0" bIns="0" anchor="t">
+            <a:spAutoFit/>
+          </a:bodyPr>
+          <a:lstStyle/>
+          <a:p>
+            <a:pPr algn="l">
+              <a:lnSpc>
+                <a:spcPct val="113000"/>
+              </a:lnSpc>
+              <a:spcAft>
+                <a:spcPts val="0"/>
+              </a:spcAft>
+            </a:pPr>
+            <a:r>
+              <a:rPr sz="880" b="0" i="0">
+                <a:solidFill>
+                  <a:srgbClr val="0E1620"/>
+                </a:solidFill>
+                <a:latin typeface="Arial"/>
+              </a:rPr>
+              <a:t>The crowd assumes a cheap, troubled company is even worse than it looks — and is often right. We play a different game: we buy good businesses hidden inside a poorly-run structure — quality at a discount, not a value trap.</a:t>
+            </a:r>
+          </a:p>
+        </p:txBody>
+      </p:sp>
+      <p:sp>
+        <p:nvSpPr>
+          <p:cNvPr id="25" name="Rectangle 24"/>
+          <p:cNvSpPr/>
+          <p:nvPr/>
+        </p:nvSpPr>
+        <p:spPr>
+          <a:xfrm>
+            <a:off x="438922" y="6388608"/>
+            <a:ext cx="8895505" cy="487680"/>
+          </a:xfrm>
+          <a:prstGeom prst="rect">
+            <a:avLst/>
+          </a:prstGeom>
+          <a:solidFill>
+            <a:srgbClr val="152130"/>
+          </a:solidFill>
+          <a:ln>
+            <a:noFill/>
+          </a:ln>
+          <a:effectLst/>
+        </p:spPr>
+        <p:style>
+          <a:lnRef idx="1">
+            <a:schemeClr val="accent1"/>
+          </a:lnRef>
+          <a:fillRef idx="3">
+            <a:schemeClr val="accent1"/>
+          </a:fillRef>
+          <a:effectRef idx="2">
+            <a:schemeClr val="accent1"/>
+          </a:effectRef>
+          <a:fontRef idx="minor">
+            <a:schemeClr val="lt1"/>
+          </a:fontRef>
+        </p:style>
+        <p:txBody>
+          <a:bodyPr rtlCol="0" anchor="ctr"/>
+          <a:lstStyle/>
+          <a:p>
+            <a:pPr algn="ctr"/>
+            <a:endParaRPr/>
+          </a:p>
+        </p:txBody>
+      </p:sp>
+      <p:sp>
+        <p:nvSpPr>
+          <p:cNvPr id="26" name="TextBox 25"/>
+          <p:cNvSpPr txBox="1"/>
+          <p:nvPr/>
+        </p:nvSpPr>
+        <p:spPr>
+          <a:xfrm>
+            <a:off x="585230" y="6388608"/>
+            <a:ext cx="8632151" cy="487680"/>
+          </a:xfrm>
+          <a:prstGeom prst="rect">
+            <a:avLst/>
+          </a:prstGeom>
+          <a:noFill/>
+        </p:spPr>
+        <p:txBody>
+          <a:bodyPr wrap="square" lIns="0" tIns="0" rIns="0" bIns="0" anchor="ctr">
+            <a:spAutoFit/>
+          </a:bodyPr>
+          <a:lstStyle/>
+          <a:p>
+            <a:pPr algn="l">
+              <a:lnSpc>
+                <a:spcPct val="110000"/>
+              </a:lnSpc>
+              <a:spcAft>
+                <a:spcPts val="0"/>
+              </a:spcAft>
+            </a:pPr>
+            <a:r>
+              <a:rPr sz="960" b="0" i="1">
+                <a:solidFill>
+                  <a:srgbClr val="FFFFFF"/>
+                </a:solidFill>
+                <a:latin typeface="Arial"/>
+              </a:rPr>
+              <a:t>Each barrier filters out the typical manager; together they keep the opportunity uncrowded — and clearing all four at once is exactly what our combination of operating and investing experience is built to do.</a:t>
+            </a:r>
           </a:p>
         </p:txBody>
       </p:sp>

</xml_diff>

<commit_message>
Clarify the two down-market measures (p.18 and p.22)
Per clarification, p.18 and p.22 measure different things over the same
period; relabel so they are not mistaken for a contradiction:
- p.18: header -> 'IN THE AVERAGE MONTH OF A DOWN YEAR'; sub-label and
  footnote updated to 'within down years' (all months of years the market
  finished down)
- p.22: now explicit it is 'any month the market fell' (down months)
No performance figures changed.

https://claude.ai/code/session_01HRMxSvt6t94q3GFGUqavQe
</commit_message>
<xml_diff>
--- a/Athanase_Endowment_Pitch_23pp.pptx
+++ b/Athanase_Endowment_Pitch_23pp.pptx
@@ -16386,7 +16386,7 @@
                 </a:solidFill>
                 <a:latin typeface="Arial"/>
               </a:rPr>
-              <a:t>IN THE AVERAGE DOWN MONTH</a:t>
+              <a:t>IN THE AVERAGE MONTH OF A DOWN YEAR</a:t>
             </a:r>
           </a:p>
         </p:txBody>
@@ -16470,7 +16470,7 @@
                 </a:solidFill>
                 <a:latin typeface="Arial"/>
               </a:rPr>
-              <a:t>Athanase — a small gain when the market is down.</a:t>
+              <a:t>Athanase — a small gain in the average month of a down year.</a:t>
             </a:r>
           </a:p>
         </p:txBody>
@@ -17412,7 +17412,7 @@
                 </a:solidFill>
                 <a:latin typeface="Arial"/>
               </a:rPr>
-              <a:t>Down-month figure: average monthly return in months the MSCI World IMI was negative. Annual figures: AIP net return − MSCI IMI. Source: Athanase, April 2026.</a:t>
+              <a:t>Down-year figure: average monthly return across all months of the years in which the MSCI World IMI finished down. Annual figures: AIP net return − MSCI IMI. Source: Athanase, April 2026.</a:t>
             </a:r>
           </a:p>
         </p:txBody>
@@ -25767,7 +25767,7 @@
                 </a:solidFill>
                 <a:latin typeface="Arial"/>
               </a:rPr>
-              <a:t>In the market’s down months Athanase fell ~1.5% on average versus the market’s ~3.8% — losing less than half as much when it matters.</a:t>
+              <a:t>In the market’s down months — any month the market fell — Athanase fell ~1.5% on average versus the market’s ~3.8%, losing less than half as much when it matters.</a:t>
             </a:r>
           </a:p>
           <a:p>

</xml_diff>